<commit_message>
refactor(ml, entregables): calibracion de RandomForest balanceado en Spark MLlib, actualizacion de metricas ROC-AUC y sincronizacion de entregables
</commit_message>
<xml_diff>
--- a/Presentacion_Defensa_Oral.pptx
+++ b/Presentacion_Defensa_Oral.pptx
@@ -4999,15 +4999,11 @@
               </a:defRPr>
             </a:pPr>
             <a:r>
-              <a:t>• Variable Objetivo: Severity (Nivel 1 a 4).</a:t>
-            </a:r>
+              <a:t>• Variable Objetivo: Alta Severidad Binaria (Severity &gt;= 3 vs &lt; 3). Mitigación del Sesgo: La clase 2 concentra 79.67% del dataset. Binarizar a siniestros críticos elimina la Paradoja de la Exactitud y prioriza el triage en ITS.</a:t>
+            </a:r>
+          </a:p>
+          <a:p>
             <a:br/>
-            <a:r>
-              <a:t>• Justificación ITS: Despacho inteligente anticipado de unidades médicas y control semafórico antes de que la congestión se vuelva irreversible.</a:t>
-            </a:r>
-          </a:p>
-          <a:p>
-            <a:br/>
             <a:pPr>
               <a:defRPr b="1" sz="1100">
                 <a:solidFill>
@@ -5028,15 +5024,7 @@
               </a:defRPr>
             </a:pPr>
             <a:r>
-              <a:t>• Clasificación Supervisada con pyspark.ml.</a:t>
-            </a:r>
-            <a:br/>
-            <a:r>
-              <a:t>• Algoritmo: DecisionTreeClassifier.</a:t>
-            </a:r>
-            <a:br/>
-            <a:r>
-              <a:t>• Hiperparámetro maxBins=60: Fundamental para absorber la alta cardinalidad de los 49 estados sin pérdida de información de splits.</a:t>
+              <a:t>• Algoritmo: RandomForestClassifier (20 árboles, maxBins=64) con Ponderación de Pesos de Clase (weightCol) para penalizar severamente los falsos negativos en colisiones graves.</a:t>
             </a:r>
           </a:p>
           <a:p>
@@ -5480,77 +5468,65 @@
               </a:defRPr>
             </a:pPr>
             <a:r>
-              <a:t>  - Partición 80% Train / 20% Test con semilla fija sobre el universo de 7.72M.</a:t>
-            </a:r>
+              <a:t>- Partición 80% Train / 20% Test con semilla fija sobre 7.07M registros limpios. Tiempo total Spark MLlib: 270.86 segundos.</a:t>
+            </a:r>
+          </a:p>
+          <a:p>
             <a:br/>
-            <a:r>
-              <a:t>  - Tiempo total de entrenamiento y scoring Spark MLlib: 245.72 segundos.</a:t>
-            </a:r>
-          </a:p>
-          <a:p>
+            <a:pPr>
+              <a:defRPr b="1" sz="1100">
+                <a:solidFill>
+                  <a:srgbClr val="F8FAFC"/>
+                </a:solidFill>
+              </a:defRPr>
+            </a:pPr>
+            <a:r>
+              <a:t>• Métricas de Evaluación Obtenidas:</a:t>
+            </a:r>
+          </a:p>
+          <a:p>
+            <a:pPr>
+              <a:defRPr sz="1000">
+                <a:solidFill>
+                  <a:srgbClr val="94A3B8"/>
+                </a:solidFill>
+              </a:defRPr>
+            </a:pPr>
+            <a:r>
+              <a:t>- ROC-AUC: 0.7012 (Capacidad discriminativa robusta que cumple la métrica obligatoria del enunciado).</a:t>
+            </a:r>
             <a:br/>
+            <a:r>
+              <a:t>- Sensibilidad / Recall en Graves: 75.50% (Detecta 198,306 accidentes críticos sobre test; 3 de cada 4).</a:t>
+            </a:r>
+            <a:br/>
+            <a:r>
+              <a:t>- PR-AUC: 0.3503 | F1-Score: 0.6071 | Accuracy post-balanceo: 56.06%.</a:t>
+            </a:r>
+          </a:p>
+          <a:p>
+            <a:br/>
             <a:pPr>
               <a:defRPr b="1" sz="1100">
                 <a:solidFill>
-                  <a:srgbClr val="F8FAFC"/>
-                </a:solidFill>
-              </a:defRPr>
-            </a:pPr>
-            <a:r>
-              <a:t>• Métricas de Evaluación Obtenidas:</a:t>
-            </a:r>
-          </a:p>
-          <a:p>
-            <a:pPr>
-              <a:defRPr sz="1000">
+                  <a:srgbClr val="2DD4BF"/>
+                </a:solidFill>
+              </a:defRPr>
+            </a:pPr>
+            <a:r>
+              <a:t>• Interpretación y Contrastación de Hipótesis:</a:t>
+            </a:r>
+          </a:p>
+          <a:p>
+            <a:pPr>
+              <a:defRPr sz="950">
                 <a:solidFill>
                   <a:srgbClr val="94A3B8"/>
                 </a:solidFill>
               </a:defRPr>
             </a:pPr>
             <a:r>
-              <a:t>  - Accuracy: 79.81% (superando significativamente el baseline del 73.2%).</a:t>
-            </a:r>
-            <a:br/>
-            <a:r>
-              <a:t>  - F1-Score Ponderado: 0.7138, demostrando robustez frente al severo desbalanceo de clases (Severidad 2 representa más del 79% del dataset total).</a:t>
-            </a:r>
-          </a:p>
-          <a:p>
-            <a:br/>
-            <a:pPr>
-              <a:defRPr b="1" sz="1100">
-                <a:solidFill>
-                  <a:srgbClr val="2DD4BF"/>
-                </a:solidFill>
-              </a:defRPr>
-            </a:pPr>
-            <a:r>
-              <a:t>• Interpretación y Contrastación de Hipótesis:</a:t>
-            </a:r>
-          </a:p>
-          <a:p>
-            <a:pPr>
-              <a:defRPr sz="950">
-                <a:solidFill>
-                  <a:srgbClr val="94A3B8"/>
-                </a:solidFill>
-              </a:defRPr>
-            </a:pPr>
-            <a:r>
-              <a:t>  - Reglas del Árbol: Los splits de mayor ganancia de información sitúan a</a:t>
-            </a:r>
-            <a:br/>
-            <a:r>
-              <a:t>    Visibilidad (&lt; 3.0 mi) y cercanía a Intercambiadores viales (Junction == True).</a:t>
-            </a:r>
-            <a:br/>
-            <a:r>
-              <a:t>  - Se confirma la hipótesis: La degradación visual extrema combinada con geometrías</a:t>
-            </a:r>
-            <a:br/>
-            <a:r>
-              <a:t>    complejas de incorporación multiplica por 4 la severidad catastrófica (Nivel 3 y 4).</a:t>
+              <a:t>- Importancia de Variables: Los predictores dominantes son Intercambiadores viales (Junction == True), Visibilidad reducida (&lt; 3 mi) y corredores interestatales de alta velocidad.</a:t>
             </a:r>
           </a:p>
         </p:txBody>

</xml_diff>